<commit_message>
Patched the presentation for seminar 2
</commit_message>
<xml_diff>
--- a/2. Докер-композиции и сеть/presentation.pptx
+++ b/2. Докер-композиции и сеть/presentation.pptx
@@ -14437,11 +14437,15 @@
           <a:p>
             <a:r>
               <a:rPr lang="ru-RU" sz="1000" dirty="0"/>
-              <a:t>Предпосылки появления</a:t>
-            </a:r>
-            <a:r>
-              <a:rPr lang="en-US" sz="1000" dirty="0"/>
-              <a:t> docker-compose</a:t>
+              <a:t>Типы </a:t>
+            </a:r>
+            <a:r>
+              <a:rPr lang="ru-RU" sz="1000" dirty="0" err="1"/>
+              <a:t>докерных</a:t>
+            </a:r>
+            <a:r>
+              <a:rPr lang="ru-RU" sz="1000" dirty="0"/>
+              <a:t> сетей</a:t>
             </a:r>
             <a:endParaRPr lang="ru-RU" dirty="0"/>
           </a:p>
@@ -15062,11 +15066,7 @@
           <a:p>
             <a:r>
               <a:rPr lang="ru-RU" sz="1000" dirty="0"/>
-              <a:t>Предпосылки появления</a:t>
-            </a:r>
-            <a:r>
-              <a:rPr lang="en-US" sz="1000" dirty="0"/>
-              <a:t> docker-compose</a:t>
+              <a:t>Управление окружением и секретами</a:t>
             </a:r>
             <a:endParaRPr lang="ru-RU" dirty="0"/>
           </a:p>
@@ -16490,7 +16490,7 @@
           <a:p>
             <a:r>
               <a:rPr lang="ru-RU" sz="1000" dirty="0"/>
-              <a:t>Полезные аспекты, о которых многие забывают</a:t>
+              <a:t>Немного безопасности</a:t>
             </a:r>
             <a:endParaRPr lang="ru-RU" dirty="0"/>
           </a:p>
@@ -17238,7 +17238,11 @@
           <a:p>
             <a:r>
               <a:rPr lang="ru-RU" sz="1000" dirty="0"/>
-              <a:t>Полезные аспекты, о которых многие забывают</a:t>
+              <a:t>Безопасность и сертификаты - </a:t>
+            </a:r>
+            <a:r>
+              <a:rPr lang="en-US" sz="1000" dirty="0"/>
+              <a:t>RSA</a:t>
             </a:r>
             <a:endParaRPr lang="ru-RU" dirty="0"/>
           </a:p>
@@ -17260,7 +17264,7 @@
         </p:nvSpPr>
         <p:spPr>
           <a:xfrm>
-            <a:off x="1787673" y="1727599"/>
+            <a:off x="1787673" y="1713592"/>
             <a:ext cx="5245561" cy="3393234"/>
           </a:xfrm>
           <a:prstGeom prst="rect">
@@ -17775,7 +17779,7 @@
           <a:p>
             <a:r>
               <a:rPr lang="ru-RU" sz="1000" dirty="0"/>
-              <a:t>Полезные аспекты, о которых многие забывают</a:t>
+              <a:t>Безопасность и сертификаты - шифрование</a:t>
             </a:r>
             <a:endParaRPr lang="ru-RU" dirty="0"/>
           </a:p>
@@ -18413,7 +18417,15 @@
           <a:p>
             <a:r>
               <a:rPr lang="ru-RU" sz="1000" dirty="0"/>
-              <a:t>Полезные аспекты, о которых многие забывают</a:t>
+              <a:t>Безопасность и сертификаты</a:t>
+            </a:r>
+            <a:r>
+              <a:rPr lang="en-US" sz="1000" dirty="0"/>
+              <a:t> - </a:t>
+            </a:r>
+            <a:r>
+              <a:rPr lang="ru-RU" sz="1000" dirty="0"/>
+              <a:t>подпись</a:t>
             </a:r>
             <a:endParaRPr lang="ru-RU" dirty="0"/>
           </a:p>
@@ -19721,7 +19733,15 @@
           <a:p>
             <a:r>
               <a:rPr lang="ru-RU" sz="1000" dirty="0"/>
-              <a:t>Безопасность и сертификаты - сертификат</a:t>
+              <a:t>Безопасность и сертификаты – проверка сертификата</a:t>
+            </a:r>
+            <a:r>
+              <a:rPr lang="en-US" sz="1000" dirty="0"/>
+              <a:t> </a:t>
+            </a:r>
+            <a:r>
+              <a:rPr lang="ru-RU" sz="1000" dirty="0"/>
+              <a:t>веб-сайта</a:t>
             </a:r>
             <a:endParaRPr lang="ru-RU" dirty="0"/>
           </a:p>
@@ -20398,11 +20418,7 @@
           <a:p>
             <a:r>
               <a:rPr lang="ru-RU" sz="1000" dirty="0"/>
-              <a:t>Предпосылки появления</a:t>
-            </a:r>
-            <a:r>
-              <a:rPr lang="en-US" sz="1000" dirty="0"/>
-              <a:t> docker-compose</a:t>
+              <a:t>Первая докер-композиция</a:t>
             </a:r>
             <a:endParaRPr lang="ru-RU" dirty="0"/>
           </a:p>
@@ -22522,11 +22538,11 @@
           <a:p>
             <a:r>
               <a:rPr lang="ru-RU" sz="1000" dirty="0"/>
-              <a:t>Предпосылки появления</a:t>
-            </a:r>
-            <a:r>
-              <a:rPr lang="en-US" sz="1000" dirty="0"/>
-              <a:t> docker-compose</a:t>
+              <a:t>Разворачиваем </a:t>
+            </a:r>
+            <a:r>
+              <a:rPr lang="en-US" sz="1000" dirty="0" err="1"/>
+              <a:t>LMS</a:t>
             </a:r>
             <a:endParaRPr lang="ru-RU" dirty="0"/>
           </a:p>
@@ -23293,11 +23309,7 @@
           <a:p>
             <a:r>
               <a:rPr lang="ru-RU" sz="1000" dirty="0"/>
-              <a:t>Предпосылки появления</a:t>
-            </a:r>
-            <a:r>
-              <a:rPr lang="en-US" sz="1000" dirty="0"/>
-              <a:t> docker-compose</a:t>
+              <a:t>Прикрываем доменом приложение</a:t>
             </a:r>
             <a:endParaRPr lang="ru-RU" dirty="0"/>
           </a:p>
@@ -23558,7 +23570,7 @@
         </p:nvSpPr>
         <p:spPr>
           <a:xfrm>
-            <a:off x="646681" y="2553070"/>
+            <a:off x="646681" y="2654670"/>
             <a:ext cx="10936386" cy="3756210"/>
           </a:xfrm>
         </p:spPr>
@@ -23750,7 +23762,7 @@
         </p:blipFill>
         <p:spPr bwMode="auto">
           <a:xfrm>
-            <a:off x="5654438" y="2497525"/>
+            <a:off x="5571888" y="2370709"/>
             <a:ext cx="4893907" cy="2263432"/>
           </a:xfrm>
           <a:prstGeom prst="rect">
@@ -23888,11 +23900,7 @@
           <a:p>
             <a:r>
               <a:rPr lang="ru-RU" sz="1000" dirty="0"/>
-              <a:t>Предпосылки появления</a:t>
-            </a:r>
-            <a:r>
-              <a:rPr lang="en-US" sz="1000" dirty="0"/>
-              <a:t> docker-compose</a:t>
+              <a:t>Создаем центр сертификации</a:t>
             </a:r>
             <a:endParaRPr lang="ru-RU" dirty="0"/>
           </a:p>
@@ -25935,15 +25943,7 @@
           <a:p>
             <a:r>
               <a:rPr lang="ru-RU" dirty="0"/>
-              <a:t>Собираем контейнер с </a:t>
-            </a:r>
-            <a:r>
-              <a:rPr lang="en-US" dirty="0"/>
-              <a:t>React-</a:t>
-            </a:r>
-            <a:r>
-              <a:rPr lang="ru-RU" dirty="0"/>
-              <a:t>сайтом – домашнее задание</a:t>
+              <a:t>А теперь проделайте это сами!</a:t>
             </a:r>
           </a:p>
         </p:txBody>
@@ -26656,15 +26656,19 @@
           <a:p>
             <a:r>
               <a:rPr lang="ru-RU" dirty="0"/>
-              <a:t>Собираем контейнер с </a:t>
+              <a:t>Поднимаем </a:t>
+            </a:r>
+            <a:r>
+              <a:rPr lang="en-US" dirty="0" err="1"/>
+              <a:t>Keycloak</a:t>
             </a:r>
             <a:r>
               <a:rPr lang="en-US" dirty="0"/>
-              <a:t>React-</a:t>
+              <a:t> </a:t>
             </a:r>
             <a:r>
               <a:rPr lang="ru-RU" dirty="0"/>
-              <a:t>сайтом – домашнее задание</a:t>
+              <a:t>– домашнее задание</a:t>
             </a:r>
           </a:p>
         </p:txBody>
@@ -32403,11 +32407,7 @@
           <a:p>
             <a:r>
               <a:rPr lang="ru-RU" sz="1000" dirty="0"/>
-              <a:t>Предпосылки появления</a:t>
-            </a:r>
-            <a:r>
-              <a:rPr lang="en-US" sz="1000" dirty="0"/>
-              <a:t> docker-compose</a:t>
+              <a:t>Вернемся к докер-композициям</a:t>
             </a:r>
             <a:endParaRPr lang="ru-RU" dirty="0"/>
           </a:p>
@@ -34394,11 +34394,7 @@
           <a:p>
             <a:r>
               <a:rPr lang="ru-RU" sz="1000" dirty="0"/>
-              <a:t>Предпосылки появления</a:t>
-            </a:r>
-            <a:r>
-              <a:rPr lang="en-US" sz="1000" dirty="0"/>
-              <a:t> docker-compose</a:t>
+              <a:t>Первая докер-композиция</a:t>
             </a:r>
             <a:endParaRPr lang="ru-RU" dirty="0"/>
           </a:p>
@@ -35210,11 +35206,11 @@
           <a:p>
             <a:r>
               <a:rPr lang="ru-RU" sz="1000" dirty="0"/>
-              <a:t>Предпосылки появления</a:t>
+              <a:t>О разрешении адресов</a:t>
             </a:r>
             <a:r>
               <a:rPr lang="en-US" sz="1000" dirty="0"/>
-              <a:t> docker-compose</a:t>
+              <a:t> (DNS)</a:t>
             </a:r>
             <a:endParaRPr lang="ru-RU" dirty="0"/>
           </a:p>
@@ -35812,11 +35808,11 @@
           <a:p>
             <a:r>
               <a:rPr lang="ru-RU" sz="1000" dirty="0"/>
-              <a:t>Предпосылки появления</a:t>
+              <a:t>О разрешении адресов</a:t>
             </a:r>
             <a:r>
               <a:rPr lang="en-US" sz="1000" dirty="0"/>
-              <a:t> docker-compose</a:t>
+              <a:t> (DNS)</a:t>
             </a:r>
             <a:endParaRPr lang="ru-RU" dirty="0"/>
           </a:p>

</xml_diff>